<commit_message>
docs: sesión 1 del proyecto en equipo
</commit_message>
<xml_diff>
--- a/static/material/UT0_Presentacion_modulo_IAW.pptx
+++ b/static/material/UT0_Presentacion_modulo_IAW.pptx
@@ -7185,7 +7185,7 @@
                 <a:ea typeface="Arial" pitchFamily="34" charset="-122"/>
                 <a:cs typeface="Arial" pitchFamily="34" charset="-120"/>
               </a:rPr>
-              <a:t>Tu servidor: máquina virtual a punto, trabajo individual</a:t>
+              <a:t>Proyecto, sesión 1: tu servidor, en equipo</a:t>
             </a:r>
             <a:endParaRPr lang="en-US" sz="1400" dirty="0"/>
           </a:p>
@@ -7437,7 +7437,7 @@
                 <a:ea typeface="Arial" pitchFamily="34" charset="-122"/>
                 <a:cs typeface="Arial" pitchFamily="34" charset="-120"/>
               </a:rPr>
-              <a:t>Hoy solo cuentan los ejercicios de la última hora. Lo demás es para arrancar.</a:t>
+              <a:t>Hoy solo se califican los ejercicios de la última hora. El cuaderno del proyecto, al final del proyecto.</a:t>
             </a:r>
             <a:endParaRPr lang="en-US" sz="1250" dirty="0"/>
           </a:p>

</xml_diff>